<commit_message>
Use photorealistic objects in money lesson
</commit_message>
<xml_diff>
--- a/material/was-ist-geld/Was-ist-Geld_Klasse-7.pptx
+++ b/material/was-ist-geld/Was-ist-Geld_Klasse-7.pptx
@@ -5417,6 +5417,34 @@
           <a:chExt cx="0" cy="0"/>
         </a:xfrm>
       </p:grpSpPr>
+      <p:pic>
+        <p:nvPicPr>
+          <p:cNvPr id="240" name="Fotorealistische Geldobjekte"/>
+          <p:cNvPicPr>
+            <a:picLocks noChangeAspect="1"/>
+          </p:cNvPicPr>
+          <p:nvPr/>
+        </p:nvPicPr>
+        <p:blipFill>
+          <a:blip r:embed="rId2"/>
+          <a:srcRect t="10000" b="10000"/>
+          <a:stretch>
+            <a:fillRect/>
+          </a:stretch>
+        </p:blipFill>
+        <p:spPr>
+          <a:xfrm>
+            <a:off x="658368" y="1737360"/>
+            <a:ext cx="10866168" cy="4328160"/>
+          </a:xfrm>
+          <a:prstGeom prst="roundRect">
+            <a:avLst/>
+          </a:prstGeom>
+          <a:ln>
+            <a:noFill/>
+          </a:ln>
+        </p:spPr>
+      </p:pic>
       <p:sp>
         <p:nvSpPr>
           <p:cNvPr id="11" name="Text 11"/>
@@ -5523,315 +5551,6 @@
                 <a:latin typeface="Aptos"/>
               </a:rPr>
               <a:t>Entscheidet zuerst allein – dann vergleicht ihr zu zweit.</a:t>
-            </a:r>
-            <a:endParaRPr lang="de-DE" sz="1800"/>
-          </a:p>
-        </p:txBody>
-      </p:sp>
-      <p:sp>
-        <p:nvSpPr>
-          <p:cNvPr id="14" name="Shape 14"/>
-          <p:cNvSpPr/>
-          <p:nvPr/>
-        </p:nvSpPr>
-        <p:spPr>
-          <a:xfrm>
-            <a:off x="658368" y="2057400"/>
-            <a:ext cx="2011680" cy="1874520"/>
-          </a:xfrm>
-          <a:prstGeom prst="roundRect">
-            <a:avLst/>
-          </a:prstGeom>
-          <a:solidFill>
-            <a:srgbClr val="FFFFFF"/>
-          </a:solidFill>
-          <a:ln w="12700">
-            <a:solidFill>
-              <a:srgbClr val="DDE3EA"/>
-            </a:solidFill>
-          </a:ln>
-        </p:spPr>
-        <p:txBody>
-          <a:bodyPr wrap="square" anchor="ctr" lIns="100000" rIns="100000" tIns="100000" bIns="100000"/>
-          <a:lstStyle/>
-          <a:p>
-            <a:pPr algn="ctr" marL="0" marR="0"/>
-            <a:r>
-              <a:rPr lang="de-DE" sz="2400" b="1">
-                <a:solidFill>
-                  <a:srgbClr val="172033"/>
-                </a:solidFill>
-                <a:latin typeface="Aptos"/>
-              </a:rPr>
-              <a:t>20-Euro-</a:t>
-            </a:r>
-            <a:endParaRPr lang="de-DE" sz="2400"/>
-          </a:p>
-          <a:p>
-            <a:pPr algn="ctr" marL="0" marR="0"/>
-            <a:r>
-              <a:rPr lang="de-DE" sz="2400" b="1">
-                <a:solidFill>
-                  <a:srgbClr val="172033"/>
-                </a:solidFill>
-                <a:latin typeface="Aptos"/>
-              </a:rPr>
-              <a:t>Schein</a:t>
-            </a:r>
-            <a:endParaRPr lang="de-DE" sz="2400"/>
-          </a:p>
-        </p:txBody>
-      </p:sp>
-      <p:sp>
-        <p:nvSpPr>
-          <p:cNvPr id="15" name="Shape 15"/>
-          <p:cNvSpPr/>
-          <p:nvPr/>
-        </p:nvSpPr>
-        <p:spPr>
-          <a:xfrm>
-            <a:off x="2852928" y="2057400"/>
-            <a:ext cx="2011680" cy="1874520"/>
-          </a:xfrm>
-          <a:prstGeom prst="roundRect">
-            <a:avLst/>
-          </a:prstGeom>
-          <a:solidFill>
-            <a:srgbClr val="FFF4D1"/>
-          </a:solidFill>
-          <a:ln w="12700">
-            <a:solidFill>
-              <a:srgbClr val="E7B84B"/>
-            </a:solidFill>
-          </a:ln>
-        </p:spPr>
-        <p:txBody>
-          <a:bodyPr wrap="square" anchor="ctr" lIns="100000" rIns="100000" tIns="100000" bIns="100000"/>
-          <a:lstStyle/>
-          <a:p>
-            <a:pPr algn="ctr" marL="0" marR="0"/>
-            <a:r>
-              <a:rPr lang="de-DE" sz="2400" b="1">
-                <a:solidFill>
-                  <a:srgbClr val="172033"/>
-                </a:solidFill>
-                <a:latin typeface="Aptos"/>
-              </a:rPr>
-              <a:t>Gold-</a:t>
-            </a:r>
-            <a:endParaRPr lang="de-DE" sz="2400"/>
-          </a:p>
-          <a:p>
-            <a:pPr algn="ctr" marL="0" marR="0"/>
-            <a:r>
-              <a:rPr lang="de-DE" sz="2400" b="1">
-                <a:solidFill>
-                  <a:srgbClr val="172033"/>
-                </a:solidFill>
-                <a:latin typeface="Aptos"/>
-              </a:rPr>
-              <a:t>barren</a:t>
-            </a:r>
-            <a:endParaRPr lang="de-DE" sz="2400"/>
-          </a:p>
-        </p:txBody>
-      </p:sp>
-      <p:sp>
-        <p:nvSpPr>
-          <p:cNvPr id="16" name="Shape 16"/>
-          <p:cNvSpPr/>
-          <p:nvPr/>
-        </p:nvSpPr>
-        <p:spPr>
-          <a:xfrm>
-            <a:off x="5047488" y="2057400"/>
-            <a:ext cx="2011680" cy="1874520"/>
-          </a:xfrm>
-          <a:prstGeom prst="roundRect">
-            <a:avLst/>
-          </a:prstGeom>
-          <a:solidFill>
-            <a:srgbClr val="EAF0FF"/>
-          </a:solidFill>
-          <a:ln w="12700">
-            <a:solidFill>
-              <a:srgbClr val="6E8BF7"/>
-            </a:solidFill>
-          </a:ln>
-        </p:spPr>
-        <p:txBody>
-          <a:bodyPr wrap="square" anchor="ctr" lIns="100000" rIns="100000" tIns="100000" bIns="100000"/>
-          <a:lstStyle/>
-          <a:p>
-            <a:pPr algn="ctr" marL="0" marR="0"/>
-            <a:r>
-              <a:rPr lang="de-DE" sz="2400" b="1">
-                <a:solidFill>
-                  <a:srgbClr val="172033"/>
-                </a:solidFill>
-                <a:latin typeface="Aptos"/>
-              </a:rPr>
-              <a:t>Kredit-</a:t>
-            </a:r>
-            <a:endParaRPr lang="de-DE" sz="2400"/>
-          </a:p>
-          <a:p>
-            <a:pPr algn="ctr" marL="0" marR="0"/>
-            <a:r>
-              <a:rPr lang="de-DE" sz="2400" b="1">
-                <a:solidFill>
-                  <a:srgbClr val="172033"/>
-                </a:solidFill>
-                <a:latin typeface="Aptos"/>
-              </a:rPr>
-              <a:t>karte</a:t>
-            </a:r>
-            <a:endParaRPr lang="de-DE" sz="2400"/>
-          </a:p>
-        </p:txBody>
-      </p:sp>
-      <p:sp>
-        <p:nvSpPr>
-          <p:cNvPr id="17" name="Shape 17"/>
-          <p:cNvSpPr/>
-          <p:nvPr/>
-        </p:nvSpPr>
-        <p:spPr>
-          <a:xfrm>
-            <a:off x="7242048" y="2057400"/>
-            <a:ext cx="2011680" cy="1874520"/>
-          </a:xfrm>
-          <a:prstGeom prst="roundRect">
-            <a:avLst/>
-          </a:prstGeom>
-          <a:solidFill>
-            <a:srgbClr val="FFF0DD"/>
-          </a:solidFill>
-          <a:ln w="12700">
-            <a:solidFill>
-              <a:srgbClr val="E99B43"/>
-            </a:solidFill>
-          </a:ln>
-        </p:spPr>
-        <p:txBody>
-          <a:bodyPr wrap="square" anchor="ctr" lIns="100000" rIns="100000" tIns="100000" bIns="100000"/>
-          <a:lstStyle/>
-          <a:p>
-            <a:pPr algn="ctr" marL="0" marR="0"/>
-            <a:r>
-              <a:rPr lang="de-DE" sz="2400" b="1">
-                <a:solidFill>
-                  <a:srgbClr val="172033"/>
-                </a:solidFill>
-                <a:latin typeface="Aptos"/>
-              </a:rPr>
-              <a:t>Bit-</a:t>
-            </a:r>
-            <a:endParaRPr lang="de-DE" sz="2400"/>
-          </a:p>
-          <a:p>
-            <a:pPr algn="ctr" marL="0" marR="0"/>
-            <a:r>
-              <a:rPr lang="de-DE" sz="2400" b="1">
-                <a:solidFill>
-                  <a:srgbClr val="172033"/>
-                </a:solidFill>
-                <a:latin typeface="Aptos"/>
-              </a:rPr>
-              <a:t>coin</a:t>
-            </a:r>
-            <a:endParaRPr lang="de-DE" sz="2400"/>
-          </a:p>
-        </p:txBody>
-      </p:sp>
-      <p:sp>
-        <p:nvSpPr>
-          <p:cNvPr id="18" name="Shape 18"/>
-          <p:cNvSpPr/>
-          <p:nvPr/>
-        </p:nvSpPr>
-        <p:spPr>
-          <a:xfrm>
-            <a:off x="9436608" y="2057400"/>
-            <a:ext cx="2011680" cy="1874520"/>
-          </a:xfrm>
-          <a:prstGeom prst="roundRect">
-            <a:avLst/>
-          </a:prstGeom>
-          <a:solidFill>
-            <a:srgbClr val="F2EAFE"/>
-          </a:solidFill>
-          <a:ln w="12700">
-            <a:solidFill>
-              <a:srgbClr val="9B74D7"/>
-            </a:solidFill>
-          </a:ln>
-        </p:spPr>
-        <p:txBody>
-          <a:bodyPr wrap="square" anchor="ctr" lIns="100000" rIns="100000" tIns="100000" bIns="100000"/>
-          <a:lstStyle/>
-          <a:p>
-            <a:pPr algn="ctr" marL="0" marR="0"/>
-            <a:r>
-              <a:rPr lang="de-DE" sz="2000" b="1">
-                <a:solidFill>
-                  <a:srgbClr val="172033"/>
-                </a:solidFill>
-                <a:latin typeface="Aptos"/>
-              </a:rPr>
-              <a:t>Einkaufs-</a:t>
-            </a:r>
-            <a:endParaRPr lang="de-DE" sz="2000"/>
-          </a:p>
-          <a:p>
-            <a:pPr algn="ctr" marL="0" marR="0"/>
-            <a:r>
-              <a:rPr lang="de-DE" sz="2000" b="1">
-                <a:solidFill>
-                  <a:srgbClr val="172033"/>
-                </a:solidFill>
-                <a:latin typeface="Aptos"/>
-              </a:rPr>
-              <a:t>gutschein</a:t>
-            </a:r>
-            <a:endParaRPr lang="de-DE" sz="2000"/>
-          </a:p>
-        </p:txBody>
-      </p:sp>
-      <p:sp>
-        <p:nvSpPr>
-          <p:cNvPr id="19" name="Shape 19"/>
-          <p:cNvSpPr/>
-          <p:nvPr/>
-        </p:nvSpPr>
-        <p:spPr>
-          <a:xfrm>
-            <a:off x="1993392" y="4434840"/>
-            <a:ext cx="8211312" cy="658368"/>
-          </a:xfrm>
-          <a:prstGeom prst="roundRect">
-            <a:avLst/>
-          </a:prstGeom>
-          <a:solidFill>
-            <a:srgbClr val="E7F8F3"/>
-          </a:solidFill>
-          <a:ln>
-            <a:noFill/>
-          </a:ln>
-        </p:spPr>
-        <p:txBody>
-          <a:bodyPr wrap="square" anchor="ctr" lIns="100000" rIns="100000" tIns="100000" bIns="100000"/>
-          <a:lstStyle/>
-          <a:p>
-            <a:pPr algn="ctr" marL="0" marR="0"/>
-            <a:r>
-              <a:rPr lang="de-DE" sz="1800" b="1">
-                <a:solidFill>
-                  <a:srgbClr val="157A65"/>
-                </a:solidFill>
-                <a:latin typeface="Aptos"/>
-              </a:rPr>
-              <a:t>Vermutung: Geld / kein Geld / unsicher</a:t>
             </a:r>
             <a:endParaRPr lang="de-DE" sz="1800"/>
           </a:p>

</xml_diff>